<commit_message>
Overview figure: remove background-reference tags
- GridMind, Grid-Agent, and Tree-of-Evidence are background references without modules; their tags are removed and ZARA moves into the freed slot
- PDF edited in place (text, then only the target logos), so every other element is unchanged; PPTX source carries the same change
- TimeClaw tags keep their short label because the longer names do not fit their rows

Co-Authored-By: Claude Opus 5.5 <noreply@anthropic.com>
</commit_message>
<xml_diff>
--- a/artifacts/overview_revision_20261025/pptx/02_main_source.pptx
+++ b/artifacts/overview_revision_20261025/pptx/02_main_source.pptx
@@ -11632,7 +11632,7 @@
           </p:nvGrpSpPr>
           <p:grpSpPr>
             <a:xfrm>
-              <a:off x="10487681" y="3278322"/>
+              <a:off x="10266750" y="2869153"/>
               <a:ext cx="1444885" cy="302084"/>
               <a:chOff x="-184411" y="1780178"/>
               <a:chExt cx="1444885" cy="302084"/>
@@ -12370,188 +12370,6 @@
             <p:spPr bwMode="auto">
               <a:xfrm>
                 <a:off x="114403" y="3481769"/>
-                <a:ext cx="266400" cy="266400"/>
-              </a:xfrm>
-              <a:prstGeom prst="rect">
-                <a:avLst/>
-              </a:prstGeom>
-              <a:noFill/>
-              <a:extLst>
-                <a:ext uri="{909E8E84-426E-40DD-AFC4-6F175D3DCCD1}">
-                  <a14:hiddenFill xmlns:a14="http://schemas.microsoft.com/office/drawing/2010/main">
-                    <a:solidFill>
-                      <a:srgbClr val="FFFFFF"/>
-                    </a:solidFill>
-                  </a14:hiddenFill>
-                </a:ext>
-              </a:extLst>
-            </p:spPr>
-          </p:pic>
-        </p:grpSp>
-        <p:grpSp>
-          <p:nvGrpSpPr>
-            <p:cNvPr id="54" name="组合 53">
-              <a:extLst>
-                <a:ext uri="{FF2B5EF4-FFF2-40B4-BE49-F238E27FC236}">
-                  <a16:creationId xmlns:a16="http://schemas.microsoft.com/office/drawing/2014/main" id="{D6A8BC62-3EAC-E94A-8D73-E86976642D2F}"/>
-                </a:ext>
-              </a:extLst>
-            </p:cNvPr>
-            <p:cNvGrpSpPr/>
-            <p:nvPr/>
-          </p:nvGrpSpPr>
-          <p:grpSpPr>
-            <a:xfrm>
-              <a:off x="10266750" y="2869153"/>
-              <a:ext cx="1826679" cy="304310"/>
-              <a:chOff x="824191" y="1613552"/>
-              <a:chExt cx="1826679" cy="304310"/>
-            </a:xfrm>
-          </p:grpSpPr>
-          <p:grpSp>
-            <p:nvGrpSpPr>
-              <p:cNvPr id="328" name="组合 327">
-                <a:extLst>
-                  <a:ext uri="{FF2B5EF4-FFF2-40B4-BE49-F238E27FC236}">
-                    <a16:creationId xmlns:a16="http://schemas.microsoft.com/office/drawing/2014/main" id="{9581FC7C-1DE6-FD4D-854D-6F86771C9FBE}"/>
-                  </a:ext>
-                </a:extLst>
-              </p:cNvPr>
-              <p:cNvGrpSpPr/>
-              <p:nvPr/>
-            </p:nvGrpSpPr>
-            <p:grpSpPr>
-              <a:xfrm>
-                <a:off x="1178002" y="1613552"/>
-                <a:ext cx="1472868" cy="285750"/>
-                <a:chOff x="1648060" y="2418385"/>
-                <a:chExt cx="1472868" cy="285750"/>
-              </a:xfrm>
-            </p:grpSpPr>
-            <p:sp>
-              <p:nvSpPr>
-                <p:cNvPr id="330" name="TextBox 98">
-                  <a:extLst>
-                    <a:ext uri="{FF2B5EF4-FFF2-40B4-BE49-F238E27FC236}">
-                      <a16:creationId xmlns:a16="http://schemas.microsoft.com/office/drawing/2014/main" id="{09FC0AEA-78B0-F34D-8F89-FE38836FF71C}"/>
-                    </a:ext>
-                  </a:extLst>
-                </p:cNvPr>
-                <p:cNvSpPr txBox="1"/>
-                <p:nvPr/>
-              </p:nvSpPr>
-              <p:spPr>
-                <a:xfrm>
-                  <a:off x="1648060" y="2418385"/>
-                  <a:ext cx="590550" cy="285750"/>
-                </a:xfrm>
-                <a:prstGeom prst="rect">
-                  <a:avLst/>
-                </a:prstGeom>
-                <a:noFill/>
-                <a:ln>
-                  <a:noFill/>
-                </a:ln>
-              </p:spPr>
-              <p:txBody>
-                <a:bodyPr wrap="none" lIns="0" tIns="0" rIns="0" bIns="0" anchor="ctr">
-                  <a:noAutofit/>
-                </a:bodyPr>
-                <a:lstStyle/>
-                <a:p>
-                  <a:pPr algn="l"/>
-                  <a:r>
-                    <a:rPr lang="en-US" altLang="zh-CN" sz="1700" b="1" dirty="0" err="1">
-                      <a:solidFill>
-                        <a:srgbClr val="303746"/>
-                      </a:solidFill>
-                      <a:latin typeface="Times New Roman"/>
-                      <a:cs typeface="Times New Roman"/>
-                    </a:rPr>
-                    <a:t>GridMind</a:t>
-                  </a:r>
-                  <a:endParaRPr lang="zh-CN" altLang="en-US" sz="1700" dirty="0"/>
-                </a:p>
-              </p:txBody>
-            </p:sp>
-            <p:sp>
-              <p:nvSpPr>
-                <p:cNvPr id="331" name="TextBox 99">
-                  <a:extLst>
-                    <a:ext uri="{FF2B5EF4-FFF2-40B4-BE49-F238E27FC236}">
-                      <a16:creationId xmlns:a16="http://schemas.microsoft.com/office/drawing/2014/main" id="{2B274886-BEE5-2D41-81B0-FA004BFD363C}"/>
-                    </a:ext>
-                  </a:extLst>
-                </p:cNvPr>
-                <p:cNvSpPr txBox="1"/>
-                <p:nvPr/>
-              </p:nvSpPr>
-              <p:spPr>
-                <a:xfrm>
-                  <a:off x="2663728" y="2454092"/>
-                  <a:ext cx="457200" cy="238125"/>
-                </a:xfrm>
-                <a:prstGeom prst="rect">
-                  <a:avLst/>
-                </a:prstGeom>
-                <a:noFill/>
-                <a:ln>
-                  <a:noFill/>
-                </a:ln>
-              </p:spPr>
-              <p:txBody>
-                <a:bodyPr wrap="none" lIns="0" tIns="0" rIns="0" bIns="0" anchor="ctr">
-                  <a:noAutofit/>
-                </a:bodyPr>
-                <a:lstStyle/>
-                <a:p>
-                  <a:pPr algn="l"/>
-                  <a:r>
-                    <a:rPr lang="en-US" altLang="zh-CN" sz="1250" b="1" dirty="0">
-                      <a:solidFill>
-                        <a:srgbClr val="B1834B"/>
-                      </a:solidFill>
-                      <a:latin typeface="Times New Roman"/>
-                      <a:ea typeface="Times New Roman"/>
-                      <a:cs typeface="Times New Roman"/>
-                    </a:rPr>
-                    <a:t>2025</a:t>
-                  </a:r>
-                  <a:endParaRPr lang="zh-CN" altLang="en-US" sz="1250" dirty="0"/>
-                </a:p>
-              </p:txBody>
-            </p:sp>
-          </p:grpSp>
-          <p:pic>
-            <p:nvPicPr>
-              <p:cNvPr id="2068" name="Picture 20">
-                <a:extLst>
-                  <a:ext uri="{FF2B5EF4-FFF2-40B4-BE49-F238E27FC236}">
-                    <a16:creationId xmlns:a16="http://schemas.microsoft.com/office/drawing/2014/main" id="{BC4EB626-A542-EB4C-B9D2-9ADA8B63D0BA}"/>
-                  </a:ext>
-                </a:extLst>
-              </p:cNvPr>
-              <p:cNvPicPr>
-                <a:picLocks noChangeAspect="1" noChangeArrowheads="1"/>
-              </p:cNvPicPr>
-              <p:nvPr/>
-            </p:nvPicPr>
-            <p:blipFill>
-              <a:blip r:embed="rId33">
-                <a:extLst>
-                  <a:ext uri="{28A0092B-C50C-407E-A947-70E740481C1C}">
-                    <a14:useLocalDpi xmlns:a14="http://schemas.microsoft.com/office/drawing/2010/main" val="0"/>
-                  </a:ext>
-                </a:extLst>
-              </a:blip>
-              <a:srcRect/>
-              <a:stretch>
-                <a:fillRect/>
-              </a:stretch>
-            </p:blipFill>
-            <p:spPr bwMode="auto">
-              <a:xfrm>
-                <a:off x="824191" y="1651462"/>
                 <a:ext cx="266400" cy="266400"/>
               </a:xfrm>
               <a:prstGeom prst="rect">
@@ -14201,188 +14019,6 @@
               <a:xfrm>
                 <a:off x="17926955" y="1661858"/>
                 <a:ext cx="266400" cy="266400"/>
-              </a:xfrm>
-              <a:prstGeom prst="rect">
-                <a:avLst/>
-              </a:prstGeom>
-              <a:noFill/>
-              <a:extLst>
-                <a:ext uri="{909E8E84-426E-40DD-AFC4-6F175D3DCCD1}">
-                  <a14:hiddenFill xmlns:a14="http://schemas.microsoft.com/office/drawing/2010/main">
-                    <a:solidFill>
-                      <a:srgbClr val="FFFFFF"/>
-                    </a:solidFill>
-                  </a14:hiddenFill>
-                </a:ext>
-              </a:extLst>
-            </p:spPr>
-          </p:pic>
-        </p:grpSp>
-        <p:grpSp>
-          <p:nvGrpSpPr>
-            <p:cNvPr id="58" name="组合 57">
-              <a:extLst>
-                <a:ext uri="{FF2B5EF4-FFF2-40B4-BE49-F238E27FC236}">
-                  <a16:creationId xmlns:a16="http://schemas.microsoft.com/office/drawing/2014/main" id="{CA0ECD90-9017-194F-BB98-CBEFDAEB4112}"/>
-                </a:ext>
-              </a:extLst>
-            </p:cNvPr>
-            <p:cNvGrpSpPr/>
-            <p:nvPr/>
-          </p:nvGrpSpPr>
-          <p:grpSpPr>
-            <a:xfrm>
-              <a:off x="14054167" y="3660992"/>
-              <a:ext cx="2017767" cy="290380"/>
-              <a:chOff x="19596681" y="3477139"/>
-              <a:chExt cx="2017767" cy="290380"/>
-            </a:xfrm>
-          </p:grpSpPr>
-          <p:grpSp>
-            <p:nvGrpSpPr>
-              <p:cNvPr id="533" name="组合 532">
-                <a:extLst>
-                  <a:ext uri="{FF2B5EF4-FFF2-40B4-BE49-F238E27FC236}">
-                    <a16:creationId xmlns:a16="http://schemas.microsoft.com/office/drawing/2014/main" id="{1AAF1A2D-1661-DE4D-BF10-74D74E9B5328}"/>
-                  </a:ext>
-                </a:extLst>
-              </p:cNvPr>
-              <p:cNvGrpSpPr/>
-              <p:nvPr/>
-            </p:nvGrpSpPr>
-            <p:grpSpPr>
-              <a:xfrm>
-                <a:off x="19939664" y="3481769"/>
-                <a:ext cx="1674784" cy="285750"/>
-                <a:chOff x="1648060" y="2418385"/>
-                <a:chExt cx="1674784" cy="285750"/>
-              </a:xfrm>
-            </p:grpSpPr>
-            <p:sp>
-              <p:nvSpPr>
-                <p:cNvPr id="535" name="TextBox 98">
-                  <a:extLst>
-                    <a:ext uri="{FF2B5EF4-FFF2-40B4-BE49-F238E27FC236}">
-                      <a16:creationId xmlns:a16="http://schemas.microsoft.com/office/drawing/2014/main" id="{DC33F49F-9EE2-1541-8809-0ABE69BA295F}"/>
-                    </a:ext>
-                  </a:extLst>
-                </p:cNvPr>
-                <p:cNvSpPr txBox="1"/>
-                <p:nvPr/>
-              </p:nvSpPr>
-              <p:spPr>
-                <a:xfrm>
-                  <a:off x="1648060" y="2418385"/>
-                  <a:ext cx="590550" cy="285750"/>
-                </a:xfrm>
-                <a:prstGeom prst="rect">
-                  <a:avLst/>
-                </a:prstGeom>
-                <a:noFill/>
-                <a:ln>
-                  <a:noFill/>
-                </a:ln>
-              </p:spPr>
-              <p:txBody>
-                <a:bodyPr wrap="none" lIns="0" tIns="0" rIns="0" bIns="0" anchor="ctr">
-                  <a:noAutofit/>
-                </a:bodyPr>
-                <a:lstStyle/>
-                <a:p>
-                  <a:pPr algn="l"/>
-                  <a:r>
-                    <a:rPr lang="en-US" altLang="zh-CN" sz="1700" b="1" dirty="0">
-                      <a:solidFill>
-                        <a:srgbClr val="303746"/>
-                      </a:solidFill>
-                      <a:latin typeface="Times New Roman"/>
-                      <a:cs typeface="Times New Roman"/>
-                    </a:rPr>
-                    <a:t>Grid-Agent</a:t>
-                  </a:r>
-                  <a:endParaRPr lang="zh-CN" altLang="en-US" sz="1700" dirty="0"/>
-                </a:p>
-              </p:txBody>
-            </p:sp>
-            <p:sp>
-              <p:nvSpPr>
-                <p:cNvPr id="536" name="TextBox 99">
-                  <a:extLst>
-                    <a:ext uri="{FF2B5EF4-FFF2-40B4-BE49-F238E27FC236}">
-                      <a16:creationId xmlns:a16="http://schemas.microsoft.com/office/drawing/2014/main" id="{D7ABC782-64D4-444A-9B0D-FEB787F62D49}"/>
-                    </a:ext>
-                  </a:extLst>
-                </p:cNvPr>
-                <p:cNvSpPr txBox="1"/>
-                <p:nvPr/>
-              </p:nvSpPr>
-              <p:spPr>
-                <a:xfrm>
-                  <a:off x="2865644" y="2440735"/>
-                  <a:ext cx="457200" cy="238125"/>
-                </a:xfrm>
-                <a:prstGeom prst="rect">
-                  <a:avLst/>
-                </a:prstGeom>
-                <a:noFill/>
-                <a:ln>
-                  <a:noFill/>
-                </a:ln>
-              </p:spPr>
-              <p:txBody>
-                <a:bodyPr wrap="none" lIns="0" tIns="0" rIns="0" bIns="0" anchor="ctr">
-                  <a:noAutofit/>
-                </a:bodyPr>
-                <a:lstStyle/>
-                <a:p>
-                  <a:pPr algn="l"/>
-                  <a:r>
-                    <a:rPr lang="en-US" altLang="zh-CN" sz="1250" b="1" dirty="0">
-                      <a:solidFill>
-                        <a:srgbClr val="B1834B"/>
-                      </a:solidFill>
-                      <a:latin typeface="Times New Roman"/>
-                      <a:ea typeface="Times New Roman"/>
-                      <a:cs typeface="Times New Roman"/>
-                    </a:rPr>
-                    <a:t>2025</a:t>
-                  </a:r>
-                  <a:endParaRPr lang="zh-CN" altLang="en-US" sz="1250" dirty="0"/>
-                </a:p>
-              </p:txBody>
-            </p:sp>
-          </p:grpSp>
-          <p:pic>
-            <p:nvPicPr>
-              <p:cNvPr id="2080" name="Picture 32">
-                <a:extLst>
-                  <a:ext uri="{FF2B5EF4-FFF2-40B4-BE49-F238E27FC236}">
-                    <a16:creationId xmlns:a16="http://schemas.microsoft.com/office/drawing/2014/main" id="{D32BA808-5B1F-9C4D-9D7C-EFE891AB5ED2}"/>
-                  </a:ext>
-                </a:extLst>
-              </p:cNvPr>
-              <p:cNvPicPr>
-                <a:picLocks noChangeAspect="1" noChangeArrowheads="1"/>
-              </p:cNvPicPr>
-              <p:nvPr/>
-            </p:nvPicPr>
-            <p:blipFill>
-              <a:blip r:embed="rId38">
-                <a:extLst>
-                  <a:ext uri="{28A0092B-C50C-407E-A947-70E740481C1C}">
-                    <a14:useLocalDpi xmlns:a14="http://schemas.microsoft.com/office/drawing/2010/main" val="0"/>
-                  </a:ext>
-                </a:extLst>
-              </a:blip>
-              <a:srcRect/>
-              <a:stretch>
-                <a:fillRect/>
-              </a:stretch>
-            </p:blipFill>
-            <p:spPr bwMode="auto">
-              <a:xfrm>
-                <a:off x="19596681" y="3477139"/>
-                <a:ext cx="288000" cy="288000"/>
               </a:xfrm>
               <a:prstGeom prst="rect">
                 <a:avLst/>
@@ -16941,188 +16577,6 @@
         </p:grpSp>
         <p:grpSp>
           <p:nvGrpSpPr>
-            <p:cNvPr id="68" name="组合 67">
-              <a:extLst>
-                <a:ext uri="{FF2B5EF4-FFF2-40B4-BE49-F238E27FC236}">
-                  <a16:creationId xmlns:a16="http://schemas.microsoft.com/office/drawing/2014/main" id="{60660CB1-D67A-0C4E-AF24-D03FF58F27D1}"/>
-                </a:ext>
-              </a:extLst>
-            </p:cNvPr>
-            <p:cNvGrpSpPr/>
-            <p:nvPr/>
-          </p:nvGrpSpPr>
-          <p:grpSpPr>
-            <a:xfrm>
-              <a:off x="19603364" y="6253200"/>
-              <a:ext cx="2385718" cy="304175"/>
-              <a:chOff x="19325941" y="1540494"/>
-              <a:chExt cx="2385718" cy="304175"/>
-            </a:xfrm>
-          </p:grpSpPr>
-          <p:grpSp>
-            <p:nvGrpSpPr>
-              <p:cNvPr id="600" name="组合 599">
-                <a:extLst>
-                  <a:ext uri="{FF2B5EF4-FFF2-40B4-BE49-F238E27FC236}">
-                    <a16:creationId xmlns:a16="http://schemas.microsoft.com/office/drawing/2014/main" id="{726C6E16-7BA0-1F42-8568-08A50A7E19E0}"/>
-                  </a:ext>
-                </a:extLst>
-              </p:cNvPr>
-              <p:cNvGrpSpPr/>
-              <p:nvPr/>
-            </p:nvGrpSpPr>
-            <p:grpSpPr>
-              <a:xfrm>
-                <a:off x="19631741" y="1558919"/>
-                <a:ext cx="2079918" cy="285750"/>
-                <a:chOff x="1648060" y="2418385"/>
-                <a:chExt cx="2079918" cy="285750"/>
-              </a:xfrm>
-            </p:grpSpPr>
-            <p:sp>
-              <p:nvSpPr>
-                <p:cNvPr id="602" name="TextBox 98">
-                  <a:extLst>
-                    <a:ext uri="{FF2B5EF4-FFF2-40B4-BE49-F238E27FC236}">
-                      <a16:creationId xmlns:a16="http://schemas.microsoft.com/office/drawing/2014/main" id="{9C5D5962-7C4C-9443-83D1-D89B2A69733F}"/>
-                    </a:ext>
-                  </a:extLst>
-                </p:cNvPr>
-                <p:cNvSpPr txBox="1"/>
-                <p:nvPr/>
-              </p:nvSpPr>
-              <p:spPr>
-                <a:xfrm>
-                  <a:off x="1648060" y="2418385"/>
-                  <a:ext cx="590550" cy="285750"/>
-                </a:xfrm>
-                <a:prstGeom prst="rect">
-                  <a:avLst/>
-                </a:prstGeom>
-                <a:noFill/>
-                <a:ln>
-                  <a:noFill/>
-                </a:ln>
-              </p:spPr>
-              <p:txBody>
-                <a:bodyPr wrap="none" lIns="0" tIns="0" rIns="0" bIns="0" anchor="ctr">
-                  <a:noAutofit/>
-                </a:bodyPr>
-                <a:lstStyle/>
-                <a:p>
-                  <a:pPr algn="l"/>
-                  <a:r>
-                    <a:rPr lang="en-US" altLang="zh-CN" sz="1700" b="1" dirty="0">
-                      <a:solidFill>
-                        <a:srgbClr val="303746"/>
-                      </a:solidFill>
-                      <a:latin typeface="Times New Roman"/>
-                      <a:cs typeface="Times New Roman"/>
-                    </a:rPr>
-                    <a:t>Tree-of-Evidence</a:t>
-                  </a:r>
-                  <a:endParaRPr lang="zh-CN" altLang="en-US" sz="1700" dirty="0"/>
-                </a:p>
-              </p:txBody>
-            </p:sp>
-            <p:sp>
-              <p:nvSpPr>
-                <p:cNvPr id="603" name="TextBox 99">
-                  <a:extLst>
-                    <a:ext uri="{FF2B5EF4-FFF2-40B4-BE49-F238E27FC236}">
-                      <a16:creationId xmlns:a16="http://schemas.microsoft.com/office/drawing/2014/main" id="{720B6401-B37A-3E40-AFFC-B860DE39122E}"/>
-                    </a:ext>
-                  </a:extLst>
-                </p:cNvPr>
-                <p:cNvSpPr txBox="1"/>
-                <p:nvPr/>
-              </p:nvSpPr>
-              <p:spPr>
-                <a:xfrm>
-                  <a:off x="3270778" y="2447765"/>
-                  <a:ext cx="457200" cy="238125"/>
-                </a:xfrm>
-                <a:prstGeom prst="rect">
-                  <a:avLst/>
-                </a:prstGeom>
-                <a:noFill/>
-                <a:ln>
-                  <a:noFill/>
-                </a:ln>
-              </p:spPr>
-              <p:txBody>
-                <a:bodyPr wrap="none" lIns="0" tIns="0" rIns="0" bIns="0" anchor="ctr">
-                  <a:noAutofit/>
-                </a:bodyPr>
-                <a:lstStyle/>
-                <a:p>
-                  <a:pPr algn="l"/>
-                  <a:r>
-                    <a:rPr lang="en-US" altLang="zh-CN" sz="1250" b="1" dirty="0">
-                      <a:solidFill>
-                        <a:srgbClr val="B1834B"/>
-                      </a:solidFill>
-                      <a:latin typeface="Times New Roman"/>
-                      <a:ea typeface="Times New Roman"/>
-                      <a:cs typeface="Times New Roman"/>
-                    </a:rPr>
-                    <a:t>2026</a:t>
-                  </a:r>
-                  <a:endParaRPr lang="zh-CN" altLang="en-US" sz="1250" dirty="0"/>
-                </a:p>
-              </p:txBody>
-            </p:sp>
-          </p:grpSp>
-          <p:pic>
-            <p:nvPicPr>
-              <p:cNvPr id="1038" name="Picture 14">
-                <a:extLst>
-                  <a:ext uri="{FF2B5EF4-FFF2-40B4-BE49-F238E27FC236}">
-                    <a16:creationId xmlns:a16="http://schemas.microsoft.com/office/drawing/2014/main" id="{BD84AF1F-AB5D-3E47-BF32-F42CADAE8437}"/>
-                  </a:ext>
-                </a:extLst>
-              </p:cNvPr>
-              <p:cNvPicPr>
-                <a:picLocks noChangeAspect="1" noChangeArrowheads="1"/>
-              </p:cNvPicPr>
-              <p:nvPr/>
-            </p:nvPicPr>
-            <p:blipFill>
-              <a:blip r:embed="rId46">
-                <a:extLst>
-                  <a:ext uri="{28A0092B-C50C-407E-A947-70E740481C1C}">
-                    <a14:useLocalDpi xmlns:a14="http://schemas.microsoft.com/office/drawing/2010/main" val="0"/>
-                  </a:ext>
-                </a:extLst>
-              </a:blip>
-              <a:srcRect/>
-              <a:stretch>
-                <a:fillRect/>
-              </a:stretch>
-            </p:blipFill>
-            <p:spPr bwMode="auto">
-              <a:xfrm>
-                <a:off x="19325941" y="1540494"/>
-                <a:ext cx="266400" cy="266400"/>
-              </a:xfrm>
-              <a:prstGeom prst="rect">
-                <a:avLst/>
-              </a:prstGeom>
-              <a:noFill/>
-              <a:extLst>
-                <a:ext uri="{909E8E84-426E-40DD-AFC4-6F175D3DCCD1}">
-                  <a14:hiddenFill xmlns:a14="http://schemas.microsoft.com/office/drawing/2010/main">
-                    <a:solidFill>
-                      <a:srgbClr val="FFFFFF"/>
-                    </a:solidFill>
-                  </a14:hiddenFill>
-                </a:ext>
-              </a:extLst>
-            </p:spPr>
-          </p:pic>
-        </p:grpSp>
-        <p:grpSp>
-          <p:nvGrpSpPr>
             <p:cNvPr id="604" name="组合 603">
               <a:extLst>
                 <a:ext uri="{FF2B5EF4-FFF2-40B4-BE49-F238E27FC236}">

</xml_diff>